<commit_message>
Update PowerPoint for song #8 in FUBC - Українські
</commit_message>
<xml_diff>
--- a/fubc-ua/8-Христові - слава вся.pptx
+++ b/fubc-ua/8-Христові - слава вся.pptx
@@ -601,7 +601,7 @@
           <a:p>
             <a:r>
               <a:rPr lang="en-US" dirty="0"/>
-              <a:t>3 · 3/3</a:t>
+              <a:t>P · 1/1</a:t>
             </a:r>
             <a:endParaRPr lang="en-US" dirty="0"/>
           </a:p>
@@ -1393,7 +1393,7 @@
           <a:p>
             <a:r>
               <a:rPr lang="en-US" dirty="0"/>
-              <a:t>3 · 1/3</a:t>
+              <a:t>3 · 1/2</a:t>
             </a:r>
             <a:endParaRPr lang="en-US" dirty="0"/>
           </a:p>
@@ -1481,7 +1481,7 @@
           <a:p>
             <a:r>
               <a:rPr lang="en-US" dirty="0"/>
-              <a:t>3 · 2/3</a:t>
+              <a:t>3 · 2/2</a:t>
             </a:r>
             <a:endParaRPr lang="en-US" dirty="0"/>
           </a:p>
@@ -1950,7 +1950,7 @@
               <a:buNone/>
             </a:pPr>
             <a:r>
-              <a:rPr lang="en-US" sz="4800" b="1" dirty="0">
+              <a:rPr lang="en-US" sz="4800" b="1" i="1" dirty="0">
                 <a:solidFill>
                   <a:srgbClr val="FFFFFF"/>
                 </a:solidFill>
@@ -1967,7 +1967,7 @@
               <a:buNone/>
             </a:pPr>
             <a:r>
-              <a:rPr lang="en-US" sz="4800" b="1" dirty="0">
+              <a:rPr lang="en-US" sz="4800" b="1" i="1" dirty="0">
                 <a:solidFill>
                   <a:srgbClr val="FFFFFF"/>
                 </a:solidFill>
@@ -1984,7 +1984,7 @@
               <a:buNone/>
             </a:pPr>
             <a:r>
-              <a:rPr lang="en-US" sz="4800" b="1" dirty="0">
+              <a:rPr lang="en-US" sz="4800" b="1" i="1" dirty="0">
                 <a:solidFill>
                   <a:srgbClr val="FFFFFF"/>
                 </a:solidFill>
@@ -2001,7 +2001,7 @@
               <a:buNone/>
             </a:pPr>
             <a:r>
-              <a:rPr lang="en-US" sz="4800" b="1" dirty="0">
+              <a:rPr lang="en-US" sz="4800" b="1" i="1" dirty="0">
                 <a:solidFill>
                   <a:srgbClr val="FFFFFF"/>
                 </a:solidFill>
@@ -2012,45 +2012,6 @@
               <a:t>Вся слава Господу!</a:t>
             </a:r>
             <a:endParaRPr lang="en-US" sz="4800" dirty="0"/>
-          </a:p>
-        </p:txBody>
-      </p:sp>
-      <p:sp>
-        <p:nvSpPr>
-          <p:cNvPr id="3" name="Text 1"/>
-          <p:cNvSpPr txBox="1"/>
-          <p:nvPr/>
-        </p:nvSpPr>
-        <p:spPr>
-          <a:xfrm>
-            <a:off x="9235440" y="6126480"/>
-            <a:ext cx="2743200" cy="548640"/>
-          </a:xfrm>
-          <a:prstGeom prst="rect">
-            <a:avLst/>
-          </a:prstGeom>
-          <a:noFill/>
-          <a:ln/>
-        </p:spPr>
-        <p:txBody>
-          <a:bodyPr wrap="square" lIns="0" tIns="0" rIns="0" bIns="0" rtlCol="0" anchor="ctr"/>
-          <a:lstStyle/>
-          <a:p>
-            <a:pPr algn="r" indent="0" marL="0">
-              <a:buNone/>
-            </a:pPr>
-            <a:r>
-              <a:rPr lang="en-US" sz="2400" dirty="0">
-                <a:solidFill>
-                  <a:srgbClr val="8A8A8A"/>
-                </a:solidFill>
-                <a:latin typeface="Arial" pitchFamily="34" charset="0"/>
-                <a:ea typeface="Arial" pitchFamily="34" charset="-122"/>
-                <a:cs typeface="Arial" pitchFamily="34" charset="-120"/>
-              </a:rPr>
-              <a:t>○ ○ ●</a:t>
-            </a:r>
-            <a:endParaRPr lang="en-US" sz="2400" dirty="0"/>
           </a:p>
         </p:txBody>
       </p:sp>
@@ -3239,23 +3200,6 @@
             </a:r>
             <a:endParaRPr lang="en-US" sz="4800" dirty="0"/>
           </a:p>
-          <a:p>
-            <a:pPr algn="ctr" indent="0" marL="0">
-              <a:buNone/>
-            </a:pPr>
-            <a:r>
-              <a:rPr lang="en-US" sz="4800" b="1" dirty="0">
-                <a:solidFill>
-                  <a:srgbClr val="FFFFFF"/>
-                </a:solidFill>
-                <a:latin typeface="Arial" pitchFamily="34" charset="0"/>
-                <a:ea typeface="Arial" pitchFamily="34" charset="-122"/>
-                <a:cs typeface="Arial" pitchFamily="34" charset="-120"/>
-              </a:rPr>
-              <a:t>І Бог назавжди серед нас</a:t>
-            </a:r>
-            <a:endParaRPr lang="en-US" sz="4800" dirty="0"/>
-          </a:p>
         </p:txBody>
       </p:sp>
       <p:sp>
@@ -3291,7 +3235,7 @@
                 <a:ea typeface="Arial" pitchFamily="34" charset="-122"/>
                 <a:cs typeface="Arial" pitchFamily="34" charset="-120"/>
               </a:rPr>
-              <a:t>● ○ ○</a:t>
+              <a:t>● ○</a:t>
             </a:r>
             <a:endParaRPr lang="en-US" sz="2400" dirty="0"/>
           </a:p>
@@ -3362,6 +3306,23 @@
                 <a:ea typeface="Arial" pitchFamily="34" charset="-122"/>
                 <a:cs typeface="Arial" pitchFamily="34" charset="-120"/>
               </a:rPr>
+              <a:t>І Бог назавжди серед нас</a:t>
+            </a:r>
+            <a:endParaRPr lang="en-US" sz="4800" dirty="0"/>
+          </a:p>
+          <a:p>
+            <a:pPr algn="ctr" indent="0" marL="0">
+              <a:buNone/>
+            </a:pPr>
+            <a:r>
+              <a:rPr lang="en-US" sz="4800" b="1" dirty="0">
+                <a:solidFill>
+                  <a:srgbClr val="FFFFFF"/>
+                </a:solidFill>
+                <a:latin typeface="Arial" pitchFamily="34" charset="0"/>
+                <a:ea typeface="Arial" pitchFamily="34" charset="-122"/>
+                <a:cs typeface="Arial" pitchFamily="34" charset="-120"/>
+              </a:rPr>
               <a:t>Засяє, мов зоря,</a:t>
             </a:r>
             <a:endParaRPr lang="en-US" sz="4800" dirty="0"/>
@@ -3397,23 +3358,6 @@
                 <a:cs typeface="Arial" pitchFamily="34" charset="-120"/>
               </a:rPr>
               <a:t>Христові — слава вся.</a:t>
-            </a:r>
-            <a:endParaRPr lang="en-US" sz="4800" dirty="0"/>
-          </a:p>
-          <a:p>
-            <a:pPr algn="ctr" indent="0" marL="0">
-              <a:buNone/>
-            </a:pPr>
-            <a:r>
-              <a:rPr lang="en-US" sz="4800" b="1" dirty="0">
-                <a:solidFill>
-                  <a:srgbClr val="FFFFFF"/>
-                </a:solidFill>
-                <a:latin typeface="Arial" pitchFamily="34" charset="0"/>
-                <a:ea typeface="Arial" pitchFamily="34" charset="-122"/>
-                <a:cs typeface="Arial" pitchFamily="34" charset="-120"/>
-              </a:rPr>
-              <a:t>P:</a:t>
             </a:r>
             <a:endParaRPr lang="en-US" sz="4800" dirty="0"/>
           </a:p>
@@ -3452,7 +3396,7 @@
                 <a:ea typeface="Arial" pitchFamily="34" charset="-122"/>
                 <a:cs typeface="Arial" pitchFamily="34" charset="-120"/>
               </a:rPr>
-              <a:t>○ ● ○</a:t>
+              <a:t>○ ●</a:t>
             </a:r>
             <a:endParaRPr lang="en-US" sz="2400" dirty="0"/>
           </a:p>

</xml_diff>